<commit_message>
wrong array init in pptx
</commit_message>
<xml_diff>
--- a/08_Arrays/08_Arrays.pptx
+++ b/08_Arrays/08_Arrays.pptx
@@ -213,7 +213,7 @@
           <a:p>
             <a:fld id="{BF336932-01FD-45AF-B110-84880AA37D65}" type="datetimeFigureOut">
               <a:rPr lang="de-AT" smtClean="0"/>
-              <a:t>27.02.2022</a:t>
+              <a:t>01.03.2022</a:t>
             </a:fld>
             <a:endParaRPr lang="de-AT"/>
           </a:p>
@@ -7669,7 +7669,25 @@
                 </a:solidFill>
                 <a:latin typeface="Cascadia Mono" panose="020B0609020000020004" pitchFamily="49" charset="0"/>
               </a:rPr>
-              <a:t> numbers   = { 2, 4, 3, 5, 5, 6, 4 };</a:t>
+              <a:t> numbers   = </a:t>
+            </a:r>
+            <a:r>
+              <a:rPr lang="en-US" sz="1800" dirty="0">
+                <a:solidFill>
+                  <a:srgbClr val="0000FF"/>
+                </a:solidFill>
+                <a:latin typeface="Cascadia Mono" panose="020B0609020000020004" pitchFamily="49" charset="0"/>
+              </a:rPr>
+              <a:t>new</a:t>
+            </a:r>
+            <a:r>
+              <a:rPr lang="en-US" sz="1800" dirty="0">
+                <a:solidFill>
+                  <a:srgbClr val="000000"/>
+                </a:solidFill>
+                <a:latin typeface="Cascadia Mono" panose="020B0609020000020004" pitchFamily="49" charset="0"/>
+              </a:rPr>
+              <a:t> [] { 2, 4, 3, 5, 5, 6, 4 };</a:t>
             </a:r>
             <a:endParaRPr lang="de-AT" dirty="0">
               <a:latin typeface="Courier New" panose="02070309020205020404" pitchFamily="49" charset="0"/>

</xml_diff>